<commit_message>
Add 8-slide cut of the COA deck and share layout code via deckkit
- Binary_Storage_and_Registers_8slides_COA.pptx: condensed 8-slide version
  (representation, storage elements, register, control, hierarchy+example,
  summary/Q&A), notes on every slide
- deckkit.py: shared drawing helpers extracted from build_deck.py
- build_deck_8.py: builder for the short deck; build_deck.py now imports the kit
- preview.py: fix line-height units and phantom trailing line so the
  layout check no longer reports false overflows

Co-authored-by: arena-agent <297053741+arena-agent@users.noreply.github.com>
</commit_message>
<xml_diff>
--- a/presentations/coa/Binary_Storage_and_Registers_COA.pptx
+++ b/presentations/coa/Binary_Storage_and_Registers_COA.pptx
@@ -5825,29 +5825,8 @@
                 </a:solidFill>
                 <a:latin typeface="Segoe UI Semibold"/>
               </a:rPr>
-              <a:t>Binary Storage</a:t>
-            </a:r>
-          </a:p>
-          <a:p>
-            <a:pPr algn="l">
-              <a:lnSpc>
-                <a:spcPct val="98000"/>
-              </a:lnSpc>
-              <a:spcBef>
-                <a:spcPts val="0"/>
-              </a:spcBef>
-              <a:spcAft>
-                <a:spcPts val="0"/>
-              </a:spcAft>
-            </a:pPr>
-            <a:r>
-              <a:rPr sz="5400" b="1" i="0">
-                <a:solidFill>
-                  <a:srgbClr val="FFFFFF"/>
-                </a:solidFill>
-                <a:latin typeface="Segoe UI Semibold"/>
-              </a:rPr>
-              <a:t>and Registers</a:t>
+              <a:t>Binary Storage
+and Registers</a:t>
             </a:r>
           </a:p>
         </p:txBody>
@@ -32283,8 +32262,8 @@
         </p:nvSpPr>
         <p:spPr>
           <a:xfrm>
-            <a:off x="8531352" y="2388743"/>
-            <a:ext cx="2743200" cy="310896"/>
+            <a:off x="8513064" y="2388743"/>
+            <a:ext cx="2962656" cy="566928"/>
           </a:xfrm>
           <a:prstGeom prst="rect">
             <a:avLst/>
@@ -32309,7 +32288,7 @@
               </a:spcAft>
             </a:pPr>
             <a:r>
-              <a:rPr sz="965" b="0" i="0">
+              <a:rPr sz="1150" b="0" i="0">
                 <a:solidFill>
                   <a:srgbClr val="4A5A69"/>
                 </a:solidFill>

</xml_diff>